<commit_message>
Apply review feedback: factual fixes, hedges and appendix updates
- System price is calculated with capacities set to infinity; base the
  TSO dependency on the area prices (Tasks 1 and 5, conclusion)
- Futures trade on Euronext Optiq and clear on Euronext Clearing; the
  futures revenue split is not public (Task 1, Task 5, BMC, App. A.5)
- Label Euronext security support as an assumption (Task 4)
- Hedge fee/competition claim in the conclusion; mark the ENTSO-E
  constraint as our inference; restate Rochet and Tirole (2003)
- EPSO-G is the group that owns Litgrid, not a TSO
- Task 4 table: Nord Pool AS labelled as the platform
- Task 5: keep the canvas discussion to the four analysed blocks
- Task 2: name sunk costs and learning effects
- Appendix A and the closing reflection updated to match

Co-Authored-By: Claude Opus 5.5 (1M context) <noreply@anthropic.com>
Claude-Session: https://claude.ai/code/session_01Ki481YZJLuj4NHmH1W34yH
</commit_message>
<xml_diff>
--- a/Images/bmc_nordpool.pptx
+++ b/Images/bmc_nordpool.pptx
@@ -2863,7 +2863,7 @@
             </a:pPr>
             <a:r>
               <a:rPr sz="1150" b="0"/>
-              <a:t>• Note: futures revenue accrues to the Euronext group</a:t>
+              <a:t>• Futures: Nord Pool supplies the underlying prices; revenue split with Euronext not public</a:t>
             </a:r>
           </a:p>
         </p:txBody>
@@ -3155,7 +3155,7 @@
             </a:pPr>
             <a:r>
               <a:rPr sz="1150" b="0"/>
-              <a:t>• Owner TSOs (34%): Statnett, Svenska kraftnät, EPSO-G</a:t>
+              <a:t>• Owner TSOs (34%): Statnett, Svenska kraftnät, Litgrid (via EPSO-G)</a:t>
             </a:r>
           </a:p>
           <a:p>

</xml_diff>